<commit_message>
Shipping Rule - Working with create page
</commit_message>
<xml_diff>
--- a/.lessons/65 Backend Shipping Rule/1 Shipping Rule - Creating necessary files and designs/1.pptx
+++ b/.lessons/65 Backend Shipping Rule/1 Shipping Rule - Creating necessary files and designs/1.pptx
@@ -3406,14 +3406,76 @@
         </p:nvPicPr>
         <p:blipFill>
           <a:blip r:embed="rId2"/>
+          <a:srcRect b="67249"/>
           <a:stretch>
             <a:fillRect/>
           </a:stretch>
         </p:blipFill>
         <p:spPr>
           <a:xfrm>
-            <a:off x="1018466" y="1909550"/>
-            <a:ext cx="10155067" cy="3038899"/>
+            <a:off x="1221666" y="713442"/>
+            <a:ext cx="10155067" cy="995285"/>
+          </a:xfrm>
+          <a:prstGeom prst="rect">
+            <a:avLst/>
+          </a:prstGeom>
+        </p:spPr>
+      </p:pic>
+      <p:pic>
+        <p:nvPicPr>
+          <p:cNvPr id="2" name="Picture 1">
+            <a:extLst>
+              <a:ext uri="{FF2B5EF4-FFF2-40B4-BE49-F238E27FC236}">
+                <a16:creationId xmlns:a16="http://schemas.microsoft.com/office/drawing/2014/main" id="{9A8D54D3-9191-FA0C-C51F-F0336E6ECA72}"/>
+              </a:ext>
+            </a:extLst>
+          </p:cNvPr>
+          <p:cNvPicPr>
+            <a:picLocks noChangeAspect="1"/>
+          </p:cNvPicPr>
+          <p:nvPr/>
+        </p:nvPicPr>
+        <p:blipFill>
+          <a:blip r:embed="rId2"/>
+          <a:srcRect t="52508"/>
+          <a:stretch>
+            <a:fillRect/>
+          </a:stretch>
+        </p:blipFill>
+        <p:spPr>
+          <a:xfrm>
+            <a:off x="1221666" y="4184073"/>
+            <a:ext cx="10155067" cy="1443249"/>
+          </a:xfrm>
+          <a:prstGeom prst="rect">
+            <a:avLst/>
+          </a:prstGeom>
+        </p:spPr>
+      </p:pic>
+      <p:pic>
+        <p:nvPicPr>
+          <p:cNvPr id="6" name="Picture 5">
+            <a:extLst>
+              <a:ext uri="{FF2B5EF4-FFF2-40B4-BE49-F238E27FC236}">
+                <a16:creationId xmlns:a16="http://schemas.microsoft.com/office/drawing/2014/main" id="{B5935AD4-DE45-6B58-B08D-7CE81C192EC6}"/>
+              </a:ext>
+            </a:extLst>
+          </p:cNvPr>
+          <p:cNvPicPr>
+            <a:picLocks noChangeAspect="1"/>
+          </p:cNvPicPr>
+          <p:nvPr/>
+        </p:nvPicPr>
+        <p:blipFill>
+          <a:blip r:embed="rId3"/>
+          <a:stretch>
+            <a:fillRect/>
+          </a:stretch>
+        </p:blipFill>
+        <p:spPr>
+          <a:xfrm>
+            <a:off x="1221666" y="2066816"/>
+            <a:ext cx="10160768" cy="1727428"/>
           </a:xfrm>
           <a:prstGeom prst="rect">
             <a:avLst/>

</xml_diff>